<commit_message>
Finalise le dossier : résultats mesurés, vérifications sur banc, V3 non mesuré
Section 5 du dossier entièrement rédigée, en séparant nettement :
- 5.1 les mesures sur la plateforme Vagrant (V1 0 %, V5 17 min 38 s,
  V6 1,2 s) ;
- 5.2 les vérifications sur banc de conteneurs (V2, V4, R2), avec un
  LISEZMOI qui précise ce que le banc reproduit et ce qu'il ne reproduit
  pas, pour qu'aucune valeur ne passe pour une mesure de la plateforme.

V3 est déclaré non mesuré : les essais sur banc varient du simple au
double, et aucun poste n'a pu reconstruire la plateforme. Mieux vaut un
scénario annoncé comme non mesuré qu'un chiffre irreproductible.

Ajoute aussi les deux sorties des reconstructions qui ont échoué : elles
étayent le constat du § 6.1 sur la dépendance à l'hôte.

Co-Authored-By: Claude Opus 5 <noreply@anthropic.com>
</commit_message>
<xml_diff>
--- a/docs/Soutenance_RESULTATS-BF_Groupe6.pptx
+++ b/docs/Soutenance_RESULTATS-BF_Groupe6.pptx
@@ -121,29 +121,29 @@
   <p:extLst>
     <p:ext uri="{521415D9-36F7-43E2-AB2F-B90AF26B5E84}">
       <p14:sectionLst xmlns:p14="http://schemas.microsoft.com/office/powerpoint/2010/main">
-        <p14:section name="Ouverture" id="{c52165f2-ce2a-94d5-684a-ebd568034186}">
+        <p14:section name="Ouverture" id="{8c3bde4d-b4fc-e1b9-13f1-fb262c720efb}">
           <p14:sldIdLst>
             <p14:sldId id="256"/>
           </p14:sldIdLst>
         </p14:section>
-        <p14:section name="Le problème" id="{9eb3cc05-fb86-b415-8e79-9805efdae309}">
+        <p14:section name="Le problème" id="{68f88d17-4b27-c48d-4dd4-7f70df571f15}">
           <p14:sldIdLst>
             <p14:sldId id="257"/>
           </p14:sldIdLst>
         </p14:section>
-        <p14:section name="Architecture" id="{b7ec864d-2a25-1224-1784-cacbbbdcae41}">
+        <p14:section name="Architecture" id="{2e8a3559-d563-ef5f-58fd-9bb6d728f452}">
           <p14:sldIdLst>
             <p14:sldId id="258"/>
             <p14:sldId id="259"/>
             <p14:sldId id="260"/>
           </p14:sldIdLst>
         </p14:section>
-        <p14:section name="Résilience" id="{90520979-6857-d8ed-a69f-dab004067904}">
+        <p14:section name="Résilience" id="{f1f0c292-59f6-8bc0-2855-dd60b064330a}">
           <p14:sldIdLst>
             <p14:sldId id="261"/>
           </p14:sldIdLst>
         </p14:section>
-        <p14:section name="Résultats" id="{bef95e16-8dd3-7fee-c695-21aff3d577dd}">
+        <p14:section name="Résultats" id="{6cffbfbb-8949-22fa-828e-3ba762d89d9c}">
           <p14:sldIdLst>
             <p14:sldId id="262"/>
             <p14:sldId id="263"/>
@@ -151,19 +151,19 @@
             <p14:sldId id="265"/>
           </p14:sldIdLst>
         </p14:section>
-        <p14:section name="Ce que nous avons appris" id="{edcec9fd-8756-f51a-7a39-f9a50b2e1e71}">
+        <p14:section name="Ce que nous avons appris" id="{556bd92f-e582-ace1-ecdf-e49aec7962e5}">
           <p14:sldIdLst>
             <p14:sldId id="266"/>
             <p14:sldId id="267"/>
           </p14:sldIdLst>
         </p14:section>
-        <p14:section name="Démonstration" id="{c0661487-cd88-ade2-f6ad-f20fb4d4aea9}">
+        <p14:section name="Démonstration" id="{c6b5f296-1618-ab85-5d59-c5599b523fc5}">
           <p14:sldIdLst>
             <p14:sldId id="268"/>
             <p14:sldId id="269"/>
           </p14:sldIdLst>
         </p14:section>
-        <p14:section name="Clôture" id="{5e09488c-c44a-0a8c-4818-c36a7ca74bb6}">
+        <p14:section name="Clôture" id="{d94b6dc0-23d3-4bc1-c866-5cdfba1141ec}">
           <p14:sldIdLst>
             <p14:sldId id="270"/>
           </p14:sldIdLst>
@@ -4702,11 +4702,11 @@
         <p:spPr>
           <a:xfrm>
             <a:off x="685800" y="1371600"/>
-            <a:ext cx="10853928" cy="1005840"/>
+            <a:ext cx="10853928" cy="914400"/>
           </a:xfrm>
           <a:prstGeom prst="roundRect">
             <a:avLst>
-              <a:gd name="adj" fmla="val 9091"/>
+              <a:gd name="adj" fmla="val 10000"/>
             </a:avLst>
           </a:prstGeom>
           <a:solidFill>
@@ -4735,7 +4735,7 @@
         </p:nvSpPr>
         <p:spPr>
           <a:xfrm>
-            <a:off x="960120" y="1591056"/>
+            <a:off x="960120" y="1545336"/>
             <a:ext cx="566928" cy="566928"/>
           </a:xfrm>
           <a:prstGeom prst="ellipse">
@@ -4760,7 +4760,7 @@
         </p:nvSpPr>
         <p:spPr>
           <a:xfrm>
-            <a:off x="960120" y="1591056"/>
+            <a:off x="960120" y="1545336"/>
             <a:ext cx="566928" cy="566928"/>
           </a:xfrm>
           <a:prstGeom prst="rect">
@@ -4796,7 +4796,7 @@
         </p:nvSpPr>
         <p:spPr>
           <a:xfrm>
-            <a:off x="1737360" y="1527048"/>
+            <a:off x="1737360" y="1481328"/>
             <a:ext cx="3749040" cy="685800"/>
           </a:xfrm>
           <a:prstGeom prst="rect">
@@ -4832,7 +4832,7 @@
         </p:nvSpPr>
         <p:spPr>
           <a:xfrm>
-            <a:off x="5669280" y="1527048"/>
+            <a:off x="5669280" y="1481328"/>
             <a:ext cx="5669280" cy="685800"/>
           </a:xfrm>
           <a:prstGeom prst="rect">
@@ -4868,12 +4868,12 @@
         </p:nvSpPr>
         <p:spPr>
           <a:xfrm>
-            <a:off x="685800" y="2560320"/>
-            <a:ext cx="10853928" cy="1005840"/>
+            <a:off x="685800" y="2468880"/>
+            <a:ext cx="10853928" cy="914400"/>
           </a:xfrm>
           <a:prstGeom prst="roundRect">
             <a:avLst>
-              <a:gd name="adj" fmla="val 9091"/>
+              <a:gd name="adj" fmla="val 10000"/>
             </a:avLst>
           </a:prstGeom>
           <a:solidFill>
@@ -4902,7 +4902,7 @@
         </p:nvSpPr>
         <p:spPr>
           <a:xfrm>
-            <a:off x="960120" y="2779776"/>
+            <a:off x="960120" y="2642616"/>
             <a:ext cx="566928" cy="566928"/>
           </a:xfrm>
           <a:prstGeom prst="ellipse">
@@ -4927,7 +4927,7 @@
         </p:nvSpPr>
         <p:spPr>
           <a:xfrm>
-            <a:off x="960120" y="2779776"/>
+            <a:off x="960120" y="2642616"/>
             <a:ext cx="566928" cy="566928"/>
           </a:xfrm>
           <a:prstGeom prst="rect">
@@ -4963,7 +4963,7 @@
         </p:nvSpPr>
         <p:spPr>
           <a:xfrm>
-            <a:off x="1737360" y="2715768"/>
+            <a:off x="1737360" y="2578608"/>
             <a:ext cx="3749040" cy="685800"/>
           </a:xfrm>
           <a:prstGeom prst="rect">
@@ -4999,7 +4999,7 @@
         </p:nvSpPr>
         <p:spPr>
           <a:xfrm>
-            <a:off x="5669280" y="2715768"/>
+            <a:off x="5669280" y="2578608"/>
             <a:ext cx="5669280" cy="685800"/>
           </a:xfrm>
           <a:prstGeom prst="rect">
@@ -5035,12 +5035,12 @@
         </p:nvSpPr>
         <p:spPr>
           <a:xfrm>
-            <a:off x="685800" y="3749040"/>
-            <a:ext cx="10853928" cy="1005840"/>
+            <a:off x="685800" y="3566160"/>
+            <a:ext cx="10853928" cy="914400"/>
           </a:xfrm>
           <a:prstGeom prst="roundRect">
             <a:avLst>
-              <a:gd name="adj" fmla="val 9091"/>
+              <a:gd name="adj" fmla="val 10000"/>
             </a:avLst>
           </a:prstGeom>
           <a:solidFill>
@@ -5069,7 +5069,7 @@
         </p:nvSpPr>
         <p:spPr>
           <a:xfrm>
-            <a:off x="960120" y="3968496"/>
+            <a:off x="960120" y="3739896"/>
             <a:ext cx="566928" cy="566928"/>
           </a:xfrm>
           <a:prstGeom prst="ellipse">
@@ -5094,7 +5094,7 @@
         </p:nvSpPr>
         <p:spPr>
           <a:xfrm>
-            <a:off x="960120" y="3968496"/>
+            <a:off x="960120" y="3739896"/>
             <a:ext cx="566928" cy="566928"/>
           </a:xfrm>
           <a:prstGeom prst="rect">
@@ -5130,7 +5130,7 @@
         </p:nvSpPr>
         <p:spPr>
           <a:xfrm>
-            <a:off x="1737360" y="3904488"/>
+            <a:off x="1737360" y="3675888"/>
             <a:ext cx="3749040" cy="685800"/>
           </a:xfrm>
           <a:prstGeom prst="rect">
@@ -5166,7 +5166,7 @@
         </p:nvSpPr>
         <p:spPr>
           <a:xfrm>
-            <a:off x="5669280" y="3904488"/>
+            <a:off x="5669280" y="3675888"/>
             <a:ext cx="5669280" cy="685800"/>
           </a:xfrm>
           <a:prstGeom prst="rect">
@@ -5202,12 +5202,12 @@
         </p:nvSpPr>
         <p:spPr>
           <a:xfrm>
-            <a:off x="685800" y="4937760"/>
-            <a:ext cx="10853928" cy="1005840"/>
+            <a:off x="685800" y="4663440"/>
+            <a:ext cx="10853928" cy="914400"/>
           </a:xfrm>
           <a:prstGeom prst="roundRect">
             <a:avLst>
-              <a:gd name="adj" fmla="val 9091"/>
+              <a:gd name="adj" fmla="val 10000"/>
             </a:avLst>
           </a:prstGeom>
           <a:solidFill>
@@ -5236,7 +5236,7 @@
         </p:nvSpPr>
         <p:spPr>
           <a:xfrm>
-            <a:off x="960120" y="5157216"/>
+            <a:off x="960120" y="4837176"/>
             <a:ext cx="566928" cy="566928"/>
           </a:xfrm>
           <a:prstGeom prst="ellipse">
@@ -5261,7 +5261,7 @@
         </p:nvSpPr>
         <p:spPr>
           <a:xfrm>
-            <a:off x="960120" y="5157216"/>
+            <a:off x="960120" y="4837176"/>
             <a:ext cx="566928" cy="566928"/>
           </a:xfrm>
           <a:prstGeom prst="rect">
@@ -5297,7 +5297,7 @@
         </p:nvSpPr>
         <p:spPr>
           <a:xfrm>
-            <a:off x="1737360" y="5093208"/>
+            <a:off x="1737360" y="4773168"/>
             <a:ext cx="3749040" cy="685800"/>
           </a:xfrm>
           <a:prstGeom prst="rect">
@@ -5333,7 +5333,7 @@
         </p:nvSpPr>
         <p:spPr>
           <a:xfrm>
-            <a:off x="5669280" y="5093208"/>
+            <a:off x="5669280" y="4773168"/>
             <a:ext cx="5669280" cy="685800"/>
           </a:xfrm>
           <a:prstGeom prst="rect">
@@ -5369,7 +5369,7 @@
         </p:nvSpPr>
         <p:spPr>
           <a:xfrm>
-            <a:off x="685800" y="6172200"/>
+            <a:off x="685800" y="5897880"/>
             <a:ext cx="10881360" cy="320040"/>
           </a:xfrm>
           <a:prstGeom prst="rect">

</xml_diff>